<commit_message>
docs: registration design after review
Back-office mails in the registration's language, token valid 5 days,
no alumni prices, and a staged rollout: trainings.arc42.org first, arc42.de's
old form pages a few weeks later, Formspark retired last. Explains why the
service gets register.arc42.org rather than its fly.dev address.

Co-Authored-By: Claude Opus 5.5 <noreply@anthropic.com>
</commit_message>
<xml_diff>
--- a/docs/registration-flow/registration-flow.pptx
+++ b/docs/registration-flow/registration-flow.pptx
@@ -1164,7 +1164,7 @@
                 <a:ea typeface="Arial" pitchFamily="34" charset="-122"/>
                 <a:cs typeface="Arial" pitchFamily="34" charset="-120"/>
               </a:rPr>
-              <a:t>It seals a confirmation token (id, booking code, email, last name, language; valid 14 days) and sends two mails via Mailjet from trainings@arc42.org: first UNBESTÄTIGT with all data to the back office, then course details and a confirm link to the registrant.</a:t>
+              <a:t>It seals a confirmation token (id, booking code, email, last name, language; valid 5 days) and sends two mails via Mailjet from trainings@arc42.org: first UNCONFIRMED with all data to the back office, then course details and a confirm link to the registrant. All mails are in the language of the registration; German ones say UNBESTÄTIGT and BESTÄTIGT.</a:t>
             </a:r>
             <a:endParaRPr lang="en-US" sz="1400" dirty="0"/>
           </a:p>
@@ -1206,7 +1206,7 @@
                 <a:ea typeface="Arial" pitchFamily="34" charset="-122"/>
                 <a:cs typeface="Arial" pitchFamily="34" charset="-120"/>
               </a:rPr>
-              <a:t>The link opens a confirm page with the course facts and one button. Pressing it sends BESTÄTIGT (same R- id) to the back office and shows the confirmed page.</a:t>
+              <a:t>The link opens a confirm page with the course facts and one button. Pressing it sends CONFIRMED (same R- id) to the back office and shows the confirmed page.</a:t>
             </a:r>
             <a:endParaRPr lang="en-US" sz="1400" dirty="0"/>
           </a:p>
@@ -1227,7 +1227,7 @@
                 <a:ea typeface="Arial" pitchFamily="34" charset="-122"/>
                 <a:cs typeface="Arial" pitchFamily="34" charset="-120"/>
               </a:rPr>
-              <a:t>The back office books on BESTÄTIGT and sends its personal reply, which also tells waiting-list registrants where they stand.</a:t>
+              <a:t>The back office books on CONFIRMED and sends its personal reply, which also tells waiting-list registrants where they stand.</a:t>
             </a:r>
             <a:endParaRPr lang="en-US" sz="1400" dirty="0"/>
           </a:p>
@@ -1376,7 +1376,7 @@
                 <a:ea typeface="Arial" pitchFamily="34" charset="-122"/>
                 <a:cs typeface="Arial" pitchFamily="34" charset="-120"/>
               </a:rPr>
-              <a:t>Unknown booking code: silent drop. Date closed since the page was loaded, or course feed unreachable: continue, flagged under Hinweise.</a:t>
+              <a:t>Unknown booking code: silent drop. Date closed since the page was loaded, or course feed unreachable: continue, flagged in the notes of the back-office mail.</a:t>
             </a:r>
             <a:endParaRPr lang="en-US" sz="1400" dirty="0"/>
           </a:p>
@@ -1439,7 +1439,7 @@
                 <a:ea typeface="Arial" pitchFamily="34" charset="-122"/>
                 <a:cs typeface="Arial" pitchFamily="34" charset="-120"/>
               </a:rPr>
-              <a:t>Token tampered with or older than 14 days: error page with a mailto link to info@arc42.de.</a:t>
+              <a:t>Token tampered with or older than 5 days: error page with a mailto link to info@arc42.de.</a:t>
             </a:r>
             <a:endParaRPr lang="en-US" sz="1400" dirty="0"/>
           </a:p>
@@ -1460,7 +1460,7 @@
                 <a:ea typeface="Arial" pitchFamily="34" charset="-122"/>
                 <a:cs typeface="Arial" pitchFamily="34" charset="-120"/>
               </a:rPr>
-              <a:t>Button pressed twice: a second BESTÄTIGT, harmless.</a:t>
+              <a:t>Button pressed twice: a second CONFIRMED, harmless.</a:t>
             </a:r>
             <a:endParaRPr lang="en-US" sz="1400" dirty="0"/>
           </a:p>
@@ -1481,7 +1481,7 @@
                 <a:ea typeface="Arial" pitchFamily="34" charset="-122"/>
                 <a:cs typeface="Arial" pitchFamily="34" charset="-120"/>
               </a:rPr>
-              <a:t>No BESTÄTIGT after 2 to 3 working days: the back office follows up if the registration looks plausible and ignores it if it looks fake.</a:t>
+              <a:t>No CONFIRMED after 2 to 3 working days: the back office follows up if the registration looks plausible and ignores it if it looks fake.</a:t>
             </a:r>
             <a:endParaRPr lang="en-US" sz="1400" dirty="0"/>
           </a:p>

</xml_diff>

<commit_message>
docs: flow diagram and slides show the waiting-list note
Co-Authored-By: Claude Opus 5.5 <noreply@anthropic.com>
</commit_message>
<xml_diff>
--- a/docs/registration-flow/registration-flow.pptx
+++ b/docs/registration-flow/registration-flow.pptx
@@ -1227,7 +1227,28 @@
                 <a:ea typeface="Arial" pitchFamily="34" charset="-122"/>
                 <a:cs typeface="Arial" pitchFamily="34" charset="-120"/>
               </a:rPr>
-              <a:t>The back office books on CONFIRMED and sends its personal reply, which also tells waiting-list registrants where they stand.</a:t>
+              <a:t>For a waiting-list date there is no separate flow: the registrant mail adds a note that the date is fully booked and the registration is a waiting-list place, and the back-office mail marks it WARTELISTE / WAITING LIST.</a:t>
+            </a:r>
+            <a:endParaRPr lang="en-US" sz="1400" dirty="0"/>
+          </a:p>
+          <a:p>
+            <a:pPr marL="342900" indent="-342900">
+              <a:spcAft>
+                <a:spcPts val="600"/>
+              </a:spcAft>
+              <a:buSzPct val="100000"/>
+              <a:buChar char="•"/>
+            </a:pPr>
+            <a:r>
+              <a:rPr lang="en-US" sz="1400" dirty="0">
+                <a:solidFill>
+                  <a:srgbClr val="000000"/>
+                </a:solidFill>
+                <a:latin typeface="Arial" pitchFamily="34" charset="0"/>
+                <a:ea typeface="Arial" pitchFamily="34" charset="-122"/>
+                <a:cs typeface="Arial" pitchFamily="34" charset="-120"/>
+              </a:rPr>
+              <a:t>The back office books on CONFIRMED and sends its personal reply.</a:t>
             </a:r>
             <a:endParaRPr lang="en-US" sz="1400" dirty="0"/>
           </a:p>

</xml_diff>